<commit_message>
Learned about Arrays Today
</commit_message>
<xml_diff>
--- a/Day 7/Hoisting.pptx
+++ b/Day 7/Hoisting.pptx
@@ -118,6 +118,11 @@
       </a:defRPr>
     </a:lvl9pPr>
   </p:defaultTextStyle>
+  <p:extLst>
+    <p:ext uri="{EFAFB233-063F-42B5-8137-9DF3F51BA10A}">
+      <p15:sldGuideLst xmlns:p15="http://schemas.microsoft.com/office/powerpoint/2012/main"/>
+    </p:ext>
+  </p:extLst>
 </p:presentation>
 </file>
 
@@ -203,7 +208,7 @@
           <a:p>
             <a:fld id="{24A6CF30-EAC9-4C96-8D3D-733F92206E15}" type="datetimeFigureOut">
               <a:rPr lang="en-US" smtClean="0"/>
-              <a:t>7/12/2026</a:t>
+              <a:t>7/13/2026</a:t>
             </a:fld>
             <a:endParaRPr lang="en-US"/>
           </a:p>
@@ -829,6 +834,13 @@
               <a:schemeClr val="lt1"/>
             </a:fontRef>
           </p:style>
+          <p:txBody>
+            <a:bodyPr/>
+            <a:lstStyle/>
+            <a:p>
+              <a:endParaRPr lang="en-US"/>
+            </a:p>
+          </p:txBody>
         </p:sp>
         <p:sp>
           <p:nvSpPr>
@@ -892,6 +904,13 @@
               <a:schemeClr val="lt1"/>
             </a:fontRef>
           </p:style>
+          <p:txBody>
+            <a:bodyPr/>
+            <a:lstStyle/>
+            <a:p>
+              <a:endParaRPr lang="en-US"/>
+            </a:p>
+          </p:txBody>
         </p:sp>
         <p:sp>
           <p:nvSpPr>
@@ -933,6 +952,13 @@
               <a:schemeClr val="lt1"/>
             </a:fontRef>
           </p:style>
+          <p:txBody>
+            <a:bodyPr/>
+            <a:lstStyle/>
+            <a:p>
+              <a:endParaRPr lang="en-US"/>
+            </a:p>
+          </p:txBody>
         </p:sp>
         <p:sp>
           <p:nvSpPr>
@@ -997,6 +1023,13 @@
               <a:schemeClr val="lt1"/>
             </a:fontRef>
           </p:style>
+          <p:txBody>
+            <a:bodyPr/>
+            <a:lstStyle/>
+            <a:p>
+              <a:endParaRPr lang="en-US"/>
+            </a:p>
+          </p:txBody>
         </p:sp>
         <p:sp>
           <p:nvSpPr>
@@ -1062,6 +1095,13 @@
               <a:schemeClr val="lt1"/>
             </a:fontRef>
           </p:style>
+          <p:txBody>
+            <a:bodyPr/>
+            <a:lstStyle/>
+            <a:p>
+              <a:endParaRPr lang="en-US"/>
+            </a:p>
+          </p:txBody>
         </p:sp>
         <p:sp>
           <p:nvSpPr>
@@ -1125,6 +1165,13 @@
               <a:schemeClr val="lt1"/>
             </a:fontRef>
           </p:style>
+          <p:txBody>
+            <a:bodyPr/>
+            <a:lstStyle/>
+            <a:p>
+              <a:endParaRPr lang="en-US"/>
+            </a:p>
+          </p:txBody>
         </p:sp>
         <p:sp>
           <p:nvSpPr>
@@ -1166,6 +1213,13 @@
               <a:schemeClr val="lt1"/>
             </a:fontRef>
           </p:style>
+          <p:txBody>
+            <a:bodyPr/>
+            <a:lstStyle/>
+            <a:p>
+              <a:endParaRPr lang="en-US"/>
+            </a:p>
+          </p:txBody>
         </p:sp>
         <p:sp>
           <p:nvSpPr>
@@ -1207,6 +1261,13 @@
               <a:schemeClr val="lt1"/>
             </a:fontRef>
           </p:style>
+          <p:txBody>
+            <a:bodyPr/>
+            <a:lstStyle/>
+            <a:p>
+              <a:endParaRPr lang="en-US"/>
+            </a:p>
+          </p:txBody>
         </p:sp>
       </p:grpSp>
       <p:sp>
@@ -1384,7 +1445,7 @@
           <a:p>
             <a:fld id="{A3295463-E464-4512-BD3F-0B23332F0024}" type="datetimeFigureOut">
               <a:rPr lang="en-US" smtClean="0"/>
-              <a:t>7/12/2026</a:t>
+              <a:t>7/13/2026</a:t>
             </a:fld>
             <a:endParaRPr lang="en-US"/>
           </a:p>
@@ -1635,7 +1696,7 @@
           <a:p>
             <a:fld id="{A3295463-E464-4512-BD3F-0B23332F0024}" type="datetimeFigureOut">
               <a:rPr lang="en-US" smtClean="0"/>
-              <a:t>7/12/2026</a:t>
+              <a:t>7/13/2026</a:t>
             </a:fld>
             <a:endParaRPr lang="en-US"/>
           </a:p>
@@ -1949,7 +2010,7 @@
           <a:p>
             <a:fld id="{A3295463-E464-4512-BD3F-0B23332F0024}" type="datetimeFigureOut">
               <a:rPr lang="en-US" smtClean="0"/>
-              <a:t>7/12/2026</a:t>
+              <a:t>7/13/2026</a:t>
             </a:fld>
             <a:endParaRPr lang="en-US"/>
           </a:p>
@@ -2290,7 +2351,7 @@
           <a:p>
             <a:fld id="{A3295463-E464-4512-BD3F-0B23332F0024}" type="datetimeFigureOut">
               <a:rPr lang="en-US" smtClean="0"/>
-              <a:t>7/12/2026</a:t>
+              <a:t>7/13/2026</a:t>
             </a:fld>
             <a:endParaRPr lang="en-US"/>
           </a:p>
@@ -2604,7 +2665,7 @@
           <a:p>
             <a:fld id="{A3295463-E464-4512-BD3F-0B23332F0024}" type="datetimeFigureOut">
               <a:rPr lang="en-US" smtClean="0"/>
-              <a:t>7/12/2026</a:t>
+              <a:t>7/13/2026</a:t>
             </a:fld>
             <a:endParaRPr lang="en-US"/>
           </a:p>
@@ -2997,7 +3058,7 @@
           <a:p>
             <a:fld id="{A3295463-E464-4512-BD3F-0B23332F0024}" type="datetimeFigureOut">
               <a:rPr lang="en-US" smtClean="0"/>
-              <a:t>7/12/2026</a:t>
+              <a:t>7/13/2026</a:t>
             </a:fld>
             <a:endParaRPr lang="en-US"/>
           </a:p>
@@ -3167,7 +3228,7 @@
           <a:p>
             <a:fld id="{A3295463-E464-4512-BD3F-0B23332F0024}" type="datetimeFigureOut">
               <a:rPr lang="en-US" smtClean="0"/>
-              <a:t>7/12/2026</a:t>
+              <a:t>7/13/2026</a:t>
             </a:fld>
             <a:endParaRPr lang="en-US"/>
           </a:p>
@@ -3347,7 +3408,7 @@
           <a:p>
             <a:fld id="{A3295463-E464-4512-BD3F-0B23332F0024}" type="datetimeFigureOut">
               <a:rPr lang="en-US" smtClean="0"/>
-              <a:t>7/12/2026</a:t>
+              <a:t>7/13/2026</a:t>
             </a:fld>
             <a:endParaRPr lang="en-US"/>
           </a:p>
@@ -3523,7 +3584,7 @@
           <a:p>
             <a:fld id="{A3295463-E464-4512-BD3F-0B23332F0024}" type="datetimeFigureOut">
               <a:rPr lang="en-US" smtClean="0"/>
-              <a:t>7/12/2026</a:t>
+              <a:t>7/13/2026</a:t>
             </a:fld>
             <a:endParaRPr lang="en-US"/>
           </a:p>
@@ -3770,7 +3831,7 @@
           <a:p>
             <a:fld id="{A3295463-E464-4512-BD3F-0B23332F0024}" type="datetimeFigureOut">
               <a:rPr lang="en-US" smtClean="0"/>
-              <a:t>7/12/2026</a:t>
+              <a:t>7/13/2026</a:t>
             </a:fld>
             <a:endParaRPr lang="en-US"/>
           </a:p>
@@ -4002,7 +4063,7 @@
           <a:p>
             <a:fld id="{A3295463-E464-4512-BD3F-0B23332F0024}" type="datetimeFigureOut">
               <a:rPr lang="en-US" smtClean="0"/>
-              <a:t>7/12/2026</a:t>
+              <a:t>7/13/2026</a:t>
             </a:fld>
             <a:endParaRPr lang="en-US"/>
           </a:p>
@@ -4376,7 +4437,7 @@
           <a:p>
             <a:fld id="{A3295463-E464-4512-BD3F-0B23332F0024}" type="datetimeFigureOut">
               <a:rPr lang="en-US" smtClean="0"/>
-              <a:t>7/12/2026</a:t>
+              <a:t>7/13/2026</a:t>
             </a:fld>
             <a:endParaRPr lang="en-US"/>
           </a:p>
@@ -4499,7 +4560,7 @@
           <a:p>
             <a:fld id="{A3295463-E464-4512-BD3F-0B23332F0024}" type="datetimeFigureOut">
               <a:rPr lang="en-US" smtClean="0"/>
-              <a:t>7/12/2026</a:t>
+              <a:t>7/13/2026</a:t>
             </a:fld>
             <a:endParaRPr lang="en-US"/>
           </a:p>
@@ -4594,7 +4655,7 @@
           <a:p>
             <a:fld id="{A3295463-E464-4512-BD3F-0B23332F0024}" type="datetimeFigureOut">
               <a:rPr lang="en-US" smtClean="0"/>
-              <a:t>7/12/2026</a:t>
+              <a:t>7/13/2026</a:t>
             </a:fld>
             <a:endParaRPr lang="en-US"/>
           </a:p>
@@ -4849,7 +4910,7 @@
           <a:p>
             <a:fld id="{A3295463-E464-4512-BD3F-0B23332F0024}" type="datetimeFigureOut">
               <a:rPr lang="en-US" smtClean="0"/>
-              <a:t>7/12/2026</a:t>
+              <a:t>7/13/2026</a:t>
             </a:fld>
             <a:endParaRPr lang="en-US"/>
           </a:p>
@@ -5112,7 +5173,7 @@
           <a:p>
             <a:fld id="{A3295463-E464-4512-BD3F-0B23332F0024}" type="datetimeFigureOut">
               <a:rPr lang="en-US" smtClean="0"/>
-              <a:t>7/12/2026</a:t>
+              <a:t>7/13/2026</a:t>
             </a:fld>
             <a:endParaRPr lang="en-US"/>
           </a:p>
@@ -5345,6 +5406,13 @@
               <a:schemeClr val="lt1"/>
             </a:fontRef>
           </p:style>
+          <p:txBody>
+            <a:bodyPr/>
+            <a:lstStyle/>
+            <a:p>
+              <a:endParaRPr lang="en-US"/>
+            </a:p>
+          </p:txBody>
         </p:sp>
         <p:sp>
           <p:nvSpPr>
@@ -5408,6 +5476,13 @@
               <a:schemeClr val="lt1"/>
             </a:fontRef>
           </p:style>
+          <p:txBody>
+            <a:bodyPr/>
+            <a:lstStyle/>
+            <a:p>
+              <a:endParaRPr lang="en-US"/>
+            </a:p>
+          </p:txBody>
         </p:sp>
         <p:sp>
           <p:nvSpPr>
@@ -5449,6 +5524,13 @@
               <a:schemeClr val="lt1"/>
             </a:fontRef>
           </p:style>
+          <p:txBody>
+            <a:bodyPr/>
+            <a:lstStyle/>
+            <a:p>
+              <a:endParaRPr lang="en-US"/>
+            </a:p>
+          </p:txBody>
         </p:sp>
         <p:sp>
           <p:nvSpPr>
@@ -5513,6 +5595,13 @@
               <a:schemeClr val="lt1"/>
             </a:fontRef>
           </p:style>
+          <p:txBody>
+            <a:bodyPr/>
+            <a:lstStyle/>
+            <a:p>
+              <a:endParaRPr lang="en-US"/>
+            </a:p>
+          </p:txBody>
         </p:sp>
         <p:sp>
           <p:nvSpPr>
@@ -5578,6 +5667,13 @@
               <a:schemeClr val="lt1"/>
             </a:fontRef>
           </p:style>
+          <p:txBody>
+            <a:bodyPr/>
+            <a:lstStyle/>
+            <a:p>
+              <a:endParaRPr lang="en-US"/>
+            </a:p>
+          </p:txBody>
         </p:sp>
         <p:sp>
           <p:nvSpPr>
@@ -5641,6 +5737,13 @@
               <a:schemeClr val="lt1"/>
             </a:fontRef>
           </p:style>
+          <p:txBody>
+            <a:bodyPr/>
+            <a:lstStyle/>
+            <a:p>
+              <a:endParaRPr lang="en-US"/>
+            </a:p>
+          </p:txBody>
         </p:sp>
         <p:sp>
           <p:nvSpPr>
@@ -5682,6 +5785,13 @@
               <a:schemeClr val="lt1"/>
             </a:fontRef>
           </p:style>
+          <p:txBody>
+            <a:bodyPr/>
+            <a:lstStyle/>
+            <a:p>
+              <a:endParaRPr lang="en-US"/>
+            </a:p>
+          </p:txBody>
         </p:sp>
         <p:sp>
           <p:nvSpPr>
@@ -5723,6 +5833,13 @@
               <a:schemeClr val="lt1"/>
             </a:fontRef>
           </p:style>
+          <p:txBody>
+            <a:bodyPr/>
+            <a:lstStyle/>
+            <a:p>
+              <a:endParaRPr lang="en-US"/>
+            </a:p>
+          </p:txBody>
         </p:sp>
       </p:grpSp>
       <p:sp>
@@ -5855,7 +5972,7 @@
           <a:p>
             <a:fld id="{A3295463-E464-4512-BD3F-0B23332F0024}" type="datetimeFigureOut">
               <a:rPr lang="en-US" smtClean="0"/>
-              <a:t>7/12/2026</a:t>
+              <a:t>7/13/2026</a:t>
             </a:fld>
             <a:endParaRPr lang="en-US"/>
           </a:p>
@@ -6564,7 +6681,7 @@
         </p:blipFill>
         <p:spPr>
           <a:xfrm>
-            <a:off x="1013206" y="2628851"/>
+            <a:off x="1013206" y="3228619"/>
             <a:ext cx="7277353" cy="1387067"/>
           </a:xfrm>
           <a:prstGeom prst="rect">
@@ -6572,6 +6689,41 @@
           </a:prstGeom>
         </p:spPr>
       </p:pic>
+      <p:sp>
+        <p:nvSpPr>
+          <p:cNvPr id="3" name="TextBox 2">
+            <a:extLst>
+              <a:ext uri="{FF2B5EF4-FFF2-40B4-BE49-F238E27FC236}">
+                <a16:creationId xmlns:a16="http://schemas.microsoft.com/office/drawing/2014/main" id="{0C35D4E5-4289-BD35-B29D-38BC72A7CD68}"/>
+              </a:ext>
+            </a:extLst>
+          </p:cNvPr>
+          <p:cNvSpPr txBox="1"/>
+          <p:nvPr/>
+        </p:nvSpPr>
+        <p:spPr>
+          <a:xfrm>
+            <a:off x="1013206" y="2721636"/>
+            <a:ext cx="8160152" cy="369332"/>
+          </a:xfrm>
+          <a:prstGeom prst="rect">
+            <a:avLst/>
+          </a:prstGeom>
+          <a:noFill/>
+        </p:spPr>
+        <p:txBody>
+          <a:bodyPr wrap="square" rtlCol="0">
+            <a:spAutoFit/>
+          </a:bodyPr>
+          <a:lstStyle/>
+          <a:p>
+            <a:r>
+              <a:rPr lang="en-US" dirty="0"/>
+              <a:t>Output:</a:t>
+            </a:r>
+          </a:p>
+        </p:txBody>
+      </p:sp>
     </p:spTree>
     <p:extLst>
       <p:ext uri="{BB962C8B-B14F-4D97-AF65-F5344CB8AC3E}">
@@ -6622,8 +6774,8 @@
         </p:nvSpPr>
         <p:spPr>
           <a:xfrm>
-            <a:off x="900294" y="704602"/>
-            <a:ext cx="8160152" cy="4278094"/>
+            <a:off x="900294" y="911079"/>
+            <a:ext cx="8160152" cy="4001095"/>
           </a:xfrm>
           <a:prstGeom prst="rect">
             <a:avLst/>
@@ -6656,13 +6808,19 @@
           </a:p>
           <a:p>
             <a:r>
+              <a:rPr lang="en-US" dirty="0"/>
+              <a:t>Hoisting is the process where JavaScript reads variable and function declarations before running the code. It stores them in memory first, so JavaScript already knows they exist when it starts executing the program</a:t>
+            </a:r>
+            <a:r>
               <a:rPr lang="en-US" b="1" dirty="0"/>
-              <a:t>Hoisting means JavaScript reads your variables and functions before it starts running your code.</a:t>
-            </a:r>
-            <a:r>
-              <a:rPr lang="en-US" dirty="0"/>
-              <a:t> It first checks what things are created in the program and keeps information about them in memory. Because of this, JavaScript already knows that a variable or function exists when it reaches that line of code.</a:t>
-            </a:r>
+              <a:t>.</a:t>
+            </a:r>
+          </a:p>
+          <a:p>
+            <a:endParaRPr lang="en-US" b="1" dirty="0"/>
+          </a:p>
+          <a:p>
+            <a:endParaRPr lang="en-US" b="1" dirty="0"/>
           </a:p>
           <a:p>
             <a:endParaRPr lang="en-US" b="1" u="sng" dirty="0"/>
@@ -6688,7 +6846,7 @@
             </a:pPr>
             <a:r>
               <a:rPr lang="en-US" dirty="0"/>
-              <a:t>It helps JavaScript know which variables and functions are available before running the code.</a:t>
+              <a:t>It helps JavaScript know which variables and functions exist before the code starts running.</a:t>
             </a:r>
           </a:p>
           <a:p>
@@ -6698,7 +6856,7 @@
             </a:pPr>
             <a:r>
               <a:rPr lang="en-US" dirty="0"/>
-              <a:t>Helps us to organize and work with our code.</a:t>
+              <a:t>It makes the code easier to organize and work with.</a:t>
             </a:r>
           </a:p>
           <a:p>
@@ -6708,7 +6866,7 @@
             </a:pPr>
             <a:r>
               <a:rPr lang="en-US" dirty="0"/>
-              <a:t>Assists in interpreting the way the program is executed and read by JavaScript.</a:t>
+              <a:t>It helps us understand how JavaScript reads and executes the program.</a:t>
             </a:r>
           </a:p>
         </p:txBody>
@@ -7025,7 +7183,7 @@
           <a:p>
             <a:r>
               <a:rPr lang="en-US" dirty="0"/>
-              <a:t>Let’s take a look at an example. As shown in the code, </a:t>
+              <a:t>Let’s look at an example. As shown in the code, </a:t>
             </a:r>
             <a:r>
               <a:rPr lang="en-US" b="1" dirty="0"/>
@@ -7064,8 +7222,8 @@
         </p:nvSpPr>
         <p:spPr>
           <a:xfrm>
-            <a:off x="930774" y="4185712"/>
-            <a:ext cx="4328944" cy="1754326"/>
+            <a:off x="900294" y="4027011"/>
+            <a:ext cx="4328944" cy="1477328"/>
           </a:xfrm>
           <a:prstGeom prst="rect">
             <a:avLst/>
@@ -7080,7 +7238,31 @@
           <a:p>
             <a:r>
               <a:rPr lang="en-US" dirty="0"/>
-              <a:t>As shown in the code this is how JavaScript treats the code after hoisting. The variable name is declared first, then it is accessed using console.log(), and finally the value "Aleena" is assigned to it.</a:t>
+              <a:t>This is how JavaScript treats the code after hoisting. The variable </a:t>
+            </a:r>
+            <a:r>
+              <a:rPr lang="en-US" b="1" dirty="0"/>
+              <a:t>name </a:t>
+            </a:r>
+            <a:r>
+              <a:rPr lang="en-US" dirty="0"/>
+              <a:t>is declared first, then it is accessed using </a:t>
+            </a:r>
+            <a:r>
+              <a:rPr lang="en-US" b="1" dirty="0"/>
+              <a:t>console.log()</a:t>
+            </a:r>
+            <a:r>
+              <a:rPr lang="en-US" dirty="0"/>
+              <a:t>, and finally the value </a:t>
+            </a:r>
+            <a:r>
+              <a:rPr lang="en-US" b="1" dirty="0"/>
+              <a:t>"Aleena" </a:t>
+            </a:r>
+            <a:r>
+              <a:rPr lang="en-US" dirty="0"/>
+              <a:t>is assigned to it.</a:t>
             </a:r>
             <a:endParaRPr lang="en-US" b="1" dirty="0"/>
           </a:p>
@@ -7200,7 +7382,7 @@
             <a:endParaRPr lang="en-US" sz="1950" dirty="0"/>
           </a:p>
           <a:p>
-            <a:endParaRPr lang="en-US" sz="1950" dirty="0"/>
+            <a:endParaRPr lang="en-US" sz="1950" b="1" dirty="0"/>
           </a:p>
           <a:p>
             <a:endParaRPr lang="en-US" sz="1950" dirty="0"/>
@@ -7230,7 +7412,7 @@
             </a:r>
             <a:r>
               <a:rPr lang="en-US" dirty="0"/>
-              <a:t>The assignment part (name = "Aleena") remains at its original position. Therefore, when the </a:t>
+              <a:t>The (name = "Aleena") remains at its original position. Therefore, when the </a:t>
             </a:r>
             <a:r>
               <a:rPr lang="en-US" b="1" dirty="0"/>
@@ -7253,10 +7435,10 @@
       </p:sp>
       <p:pic>
         <p:nvPicPr>
-          <p:cNvPr id="7" name="Picture 6">
+          <p:cNvPr id="6" name="Picture 5">
             <a:extLst>
               <a:ext uri="{FF2B5EF4-FFF2-40B4-BE49-F238E27FC236}">
-                <a16:creationId xmlns:a16="http://schemas.microsoft.com/office/drawing/2014/main" id="{CD3F838A-76B7-55DE-9C53-5354F35347FA}"/>
+                <a16:creationId xmlns:a16="http://schemas.microsoft.com/office/drawing/2014/main" id="{732F56A0-775F-879B-2B3B-3072AE544220}"/>
               </a:ext>
             </a:extLst>
           </p:cNvPr>
@@ -7273,8 +7455,8 @@
         </p:blipFill>
         <p:spPr>
           <a:xfrm>
-            <a:off x="1052578" y="2753316"/>
-            <a:ext cx="6794832" cy="1178604"/>
+            <a:off x="1006676" y="2745158"/>
+            <a:ext cx="6226080" cy="1112616"/>
           </a:xfrm>
           <a:prstGeom prst="rect">
             <a:avLst/>
@@ -7349,12 +7531,82 @@
           </a:p>
         </p:txBody>
       </p:sp>
+      <p:sp>
+        <p:nvSpPr>
+          <p:cNvPr id="5" name="TextBox 4">
+            <a:extLst>
+              <a:ext uri="{FF2B5EF4-FFF2-40B4-BE49-F238E27FC236}">
+                <a16:creationId xmlns:a16="http://schemas.microsoft.com/office/drawing/2014/main" id="{C33980A6-BB70-14D1-F042-771903D36AD5}"/>
+              </a:ext>
+            </a:extLst>
+          </p:cNvPr>
+          <p:cNvSpPr txBox="1"/>
+          <p:nvPr/>
+        </p:nvSpPr>
+        <p:spPr>
+          <a:xfrm>
+            <a:off x="1066438" y="874767"/>
+            <a:ext cx="5879690" cy="383458"/>
+          </a:xfrm>
+          <a:prstGeom prst="rect">
+            <a:avLst/>
+          </a:prstGeom>
+          <a:noFill/>
+        </p:spPr>
+        <p:txBody>
+          <a:bodyPr wrap="square" rtlCol="0">
+            <a:spAutoFit/>
+          </a:bodyPr>
+          <a:lstStyle/>
+          <a:p>
+            <a:r>
+              <a:rPr lang="en-US" dirty="0"/>
+              <a:t>This is how JavaScript will read it:</a:t>
+            </a:r>
+          </a:p>
+        </p:txBody>
+      </p:sp>
+      <p:sp>
+        <p:nvSpPr>
+          <p:cNvPr id="7" name="TextBox 6">
+            <a:extLst>
+              <a:ext uri="{FF2B5EF4-FFF2-40B4-BE49-F238E27FC236}">
+                <a16:creationId xmlns:a16="http://schemas.microsoft.com/office/drawing/2014/main" id="{186AD45B-6604-2A06-222C-9C47A9BBA95F}"/>
+              </a:ext>
+            </a:extLst>
+          </p:cNvPr>
+          <p:cNvSpPr txBox="1"/>
+          <p:nvPr/>
+        </p:nvSpPr>
+        <p:spPr>
+          <a:xfrm>
+            <a:off x="1066438" y="3045542"/>
+            <a:ext cx="5879690" cy="383458"/>
+          </a:xfrm>
+          <a:prstGeom prst="rect">
+            <a:avLst/>
+          </a:prstGeom>
+          <a:noFill/>
+        </p:spPr>
+        <p:txBody>
+          <a:bodyPr wrap="square" rtlCol="0">
+            <a:spAutoFit/>
+          </a:bodyPr>
+          <a:lstStyle/>
+          <a:p>
+            <a:r>
+              <a:rPr lang="en-US" dirty="0"/>
+              <a:t>Output:</a:t>
+            </a:r>
+          </a:p>
+        </p:txBody>
+      </p:sp>
       <p:pic>
         <p:nvPicPr>
-          <p:cNvPr id="3" name="Picture 2">
+          <p:cNvPr id="9" name="Picture 8">
             <a:extLst>
               <a:ext uri="{FF2B5EF4-FFF2-40B4-BE49-F238E27FC236}">
-                <a16:creationId xmlns:a16="http://schemas.microsoft.com/office/drawing/2014/main" id="{499A1E5E-809D-CC58-D4E9-676937F1E206}"/>
+                <a16:creationId xmlns:a16="http://schemas.microsoft.com/office/drawing/2014/main" id="{19F4DAA1-F221-43DC-F70C-D6D16E6E8B06}"/>
               </a:ext>
             </a:extLst>
           </p:cNvPr>
@@ -7371,8 +7623,8 @@
         </p:blipFill>
         <p:spPr>
           <a:xfrm>
-            <a:off x="1165599" y="704602"/>
-            <a:ext cx="6020322" cy="1234547"/>
+            <a:off x="1197778" y="1408171"/>
+            <a:ext cx="6492803" cy="1303133"/>
           </a:xfrm>
           <a:prstGeom prst="rect">
             <a:avLst/>
@@ -7430,7 +7682,7 @@
         <p:spPr>
           <a:xfrm>
             <a:off x="900294" y="623322"/>
-            <a:ext cx="8160152" cy="5478423"/>
+            <a:ext cx="7781590" cy="4793620"/>
           </a:xfrm>
           <a:prstGeom prst="rect">
             <a:avLst/>
@@ -7472,84 +7724,69 @@
             </a:r>
             <a:r>
               <a:rPr lang="en-US" dirty="0"/>
-              <a:t>. Variables declared with let are also hoisted, but JavaScript does not initialize them with any value. Instead, they remain inside the </a:t>
+              <a:t>. </a:t>
+            </a:r>
+          </a:p>
+          <a:p>
+            <a:endParaRPr lang="en-US" sz="1950" dirty="0"/>
+          </a:p>
+          <a:p>
+            <a:endParaRPr lang="en-US" sz="1950" dirty="0"/>
+          </a:p>
+          <a:p>
+            <a:endParaRPr lang="en-US" sz="1950" dirty="0"/>
+          </a:p>
+          <a:p>
+            <a:endParaRPr lang="en-US" sz="1950" dirty="0"/>
+          </a:p>
+          <a:p>
+            <a:endParaRPr lang="en-US" sz="1950" dirty="0"/>
+          </a:p>
+          <a:p>
+            <a:r>
+              <a:rPr lang="en-US" dirty="0"/>
+              <a:t>During hoisting, JavaScript creates the variable </a:t>
             </a:r>
             <a:r>
               <a:rPr lang="en-US" b="1" dirty="0"/>
-              <a:t>Temporal Dead Zone (TDZ)</a:t>
+              <a:t>age</a:t>
             </a:r>
             <a:r>
               <a:rPr lang="en-US" dirty="0"/>
-              <a:t> until the declaration line is executed. Because of this, we cannot access a let variable before its declaration.</a:t>
-            </a:r>
-            <a:endParaRPr lang="en-US" u="sng" dirty="0">
-              <a:solidFill>
-                <a:schemeClr val="accent2"/>
-              </a:solidFill>
-            </a:endParaRPr>
-          </a:p>
-          <a:p>
-            <a:endParaRPr lang="en-US" u="sng" dirty="0">
-              <a:solidFill>
-                <a:schemeClr val="accent2"/>
-              </a:solidFill>
-            </a:endParaRPr>
-          </a:p>
-          <a:p>
-            <a:endParaRPr lang="en-US" sz="1950" dirty="0"/>
-          </a:p>
-          <a:p>
-            <a:endParaRPr lang="en-US" sz="1950" dirty="0"/>
-          </a:p>
-          <a:p>
-            <a:endParaRPr lang="en-US" sz="1950" dirty="0"/>
-          </a:p>
-          <a:p>
-            <a:endParaRPr lang="en-US" sz="1950" dirty="0"/>
-          </a:p>
-          <a:p>
-            <a:endParaRPr lang="en-US" sz="1950" dirty="0"/>
-          </a:p>
-          <a:p>
-            <a:r>
-              <a:rPr lang="en-US" sz="2000" dirty="0"/>
-              <a:t>During hoisting, JavaScript creates the variable </a:t>
+              <a:t>, but it does not assign any value to it. The variable stays in the </a:t>
+            </a:r>
+            <a:r>
+              <a:rPr lang="en-US" b="1" dirty="0"/>
+              <a:t>Temporal Dead Zone (TDZ). </a:t>
             </a:r>
             <a:r>
               <a:rPr lang="en-US" dirty="0"/>
-              <a:t>age</a:t>
-            </a:r>
-            <a:r>
-              <a:rPr lang="en-US" sz="2000" dirty="0"/>
-              <a:t>, but it does not assign any value to it. The variable stays in the </a:t>
-            </a:r>
-            <a:r>
-              <a:rPr lang="en-US" sz="2000" b="1" dirty="0"/>
-              <a:t>Temporal Dead Zone (TDZ)</a:t>
-            </a:r>
-            <a:r>
-              <a:rPr lang="en-US" sz="2000" dirty="0"/>
-              <a:t>. When </a:t>
+              <a:t>Since JavaScript executes code synchronously, it runs the program line by line from top to bottom. When it reaches </a:t>
+            </a:r>
+            <a:r>
+              <a:rPr lang="en-US" b="1" dirty="0"/>
+              <a:t>console.log(age)</a:t>
             </a:r>
             <a:r>
               <a:rPr lang="en-US" dirty="0"/>
-              <a:t>console.log(age)</a:t>
-            </a:r>
-            <a:r>
-              <a:rPr lang="en-US" sz="2000" dirty="0"/>
-              <a:t> tries to access the variable before the declaration, JavaScript stops execution and gives a </a:t>
+              <a:t>, the variable is still in the </a:t>
+            </a:r>
+            <a:r>
+              <a:rPr lang="en-US" b="1" dirty="0"/>
+              <a:t>TDZ</a:t>
             </a:r>
             <a:r>
               <a:rPr lang="en-US" dirty="0"/>
+              <a:t> because the declaration has not been executed yet. As a result, JavaScript shows a </a:t>
+            </a:r>
+            <a:r>
+              <a:rPr lang="en-US" b="1" dirty="0"/>
               <a:t>ReferenceError</a:t>
             </a:r>
             <a:r>
-              <a:rPr lang="en-US" sz="2000" dirty="0"/>
-              <a:t>.</a:t>
-            </a:r>
-            <a:endParaRPr lang="en-US" sz="1950" dirty="0"/>
-          </a:p>
-          <a:p>
+              <a:rPr lang="en-US" dirty="0"/>
+              <a:t> and stops executing the remaining code.</a:t>
+            </a:r>
             <a:endParaRPr lang="en-US" sz="1850" dirty="0"/>
           </a:p>
           <a:p>
@@ -7579,7 +7816,7 @@
         </p:blipFill>
         <p:spPr>
           <a:xfrm>
-            <a:off x="986539" y="2953976"/>
+            <a:off x="996371" y="1937996"/>
             <a:ext cx="6643621" cy="1140913"/>
           </a:xfrm>
           <a:prstGeom prst="rect">
@@ -7623,38 +7860,6 @@
           <a:chExt cx="0" cy="0"/>
         </a:xfrm>
       </p:grpSpPr>
-      <p:sp>
-        <p:nvSpPr>
-          <p:cNvPr id="4" name="TextBox 3">
-            <a:extLst>
-              <a:ext uri="{FF2B5EF4-FFF2-40B4-BE49-F238E27FC236}">
-                <a16:creationId xmlns:a16="http://schemas.microsoft.com/office/drawing/2014/main" id="{F4AFC5DC-32A9-4395-CB5D-D02AFA051133}"/>
-              </a:ext>
-            </a:extLst>
-          </p:cNvPr>
-          <p:cNvSpPr txBox="1"/>
-          <p:nvPr/>
-        </p:nvSpPr>
-        <p:spPr>
-          <a:xfrm>
-            <a:off x="987779" y="2208282"/>
-            <a:ext cx="8160152" cy="369332"/>
-          </a:xfrm>
-          <a:prstGeom prst="rect">
-            <a:avLst/>
-          </a:prstGeom>
-          <a:noFill/>
-        </p:spPr>
-        <p:txBody>
-          <a:bodyPr wrap="square" rtlCol="0">
-            <a:spAutoFit/>
-          </a:bodyPr>
-          <a:lstStyle/>
-          <a:p>
-            <a:endParaRPr lang="en-US" dirty="0"/>
-          </a:p>
-        </p:txBody>
-      </p:sp>
       <p:pic>
         <p:nvPicPr>
           <p:cNvPr id="5" name="Picture 4">
@@ -7677,8 +7882,188 @@
         </p:blipFill>
         <p:spPr>
           <a:xfrm>
-            <a:off x="987779" y="704602"/>
+            <a:off x="1095935" y="2664243"/>
             <a:ext cx="6477561" cy="1265030"/>
+          </a:xfrm>
+          <a:prstGeom prst="rect">
+            <a:avLst/>
+          </a:prstGeom>
+        </p:spPr>
+      </p:pic>
+      <p:sp>
+        <p:nvSpPr>
+          <p:cNvPr id="3" name="TextBox 2">
+            <a:extLst>
+              <a:ext uri="{FF2B5EF4-FFF2-40B4-BE49-F238E27FC236}">
+                <a16:creationId xmlns:a16="http://schemas.microsoft.com/office/drawing/2014/main" id="{828B9D0E-8517-8E32-9495-60D0E64E1F0E}"/>
+              </a:ext>
+            </a:extLst>
+          </p:cNvPr>
+          <p:cNvSpPr txBox="1"/>
+          <p:nvPr/>
+        </p:nvSpPr>
+        <p:spPr>
+          <a:xfrm>
+            <a:off x="1056605" y="786093"/>
+            <a:ext cx="7654776" cy="1138773"/>
+          </a:xfrm>
+          <a:prstGeom prst="rect">
+            <a:avLst/>
+          </a:prstGeom>
+          <a:solidFill>
+            <a:schemeClr val="accent1">
+              <a:lumMod val="20000"/>
+              <a:lumOff val="80000"/>
+            </a:schemeClr>
+          </a:solidFill>
+        </p:spPr>
+        <p:txBody>
+          <a:bodyPr wrap="square" rtlCol="0">
+            <a:spAutoFit/>
+          </a:bodyPr>
+          <a:lstStyle/>
+          <a:p>
+            <a:pPr marL="285750" indent="-285750">
+              <a:buFont typeface="Wingdings" panose="05000000000000000000" pitchFamily="2" charset="2"/>
+              <a:buChar char="ü"/>
+            </a:pPr>
+            <a:r>
+              <a:rPr lang="en-US" sz="1700" b="1" dirty="0">
+                <a:solidFill>
+                  <a:schemeClr val="accent1">
+                    <a:lumMod val="75000"/>
+                  </a:schemeClr>
+                </a:solidFill>
+              </a:rPr>
+              <a:t>What is a Temporal Dead Zone (TDZ)?</a:t>
+            </a:r>
+          </a:p>
+          <a:p>
+            <a:r>
+              <a:rPr lang="en-US" sz="1700" dirty="0"/>
+              <a:t>It is the time between when a </a:t>
+            </a:r>
+            <a:r>
+              <a:rPr lang="en-US" sz="1700" b="1" dirty="0"/>
+              <a:t>let</a:t>
+            </a:r>
+            <a:r>
+              <a:rPr lang="en-US" sz="1700" dirty="0"/>
+              <a:t> or </a:t>
+            </a:r>
+            <a:r>
+              <a:rPr lang="en-US" sz="1700" b="1" dirty="0"/>
+              <a:t>const</a:t>
+            </a:r>
+            <a:r>
+              <a:rPr lang="en-US" sz="1700" dirty="0"/>
+              <a:t> variable is created and when it gets its value. During this time, the variables cannot be used and If we try to access it before its declaration, JavaScript gives a </a:t>
+            </a:r>
+            <a:r>
+              <a:rPr lang="en-US" sz="1700" b="1" dirty="0"/>
+              <a:t>ReferenceError</a:t>
+            </a:r>
+            <a:r>
+              <a:rPr lang="en-US" sz="1700" dirty="0"/>
+              <a:t>.</a:t>
+            </a:r>
+          </a:p>
+        </p:txBody>
+      </p:sp>
+      <p:sp>
+        <p:nvSpPr>
+          <p:cNvPr id="7" name="TextBox 6">
+            <a:extLst>
+              <a:ext uri="{FF2B5EF4-FFF2-40B4-BE49-F238E27FC236}">
+                <a16:creationId xmlns:a16="http://schemas.microsoft.com/office/drawing/2014/main" id="{3A27F2F6-1AFB-7A21-CDF6-1E39C83DE800}"/>
+              </a:ext>
+            </a:extLst>
+          </p:cNvPr>
+          <p:cNvSpPr txBox="1"/>
+          <p:nvPr/>
+        </p:nvSpPr>
+        <p:spPr>
+          <a:xfrm>
+            <a:off x="987779" y="2251289"/>
+            <a:ext cx="5879690" cy="383458"/>
+          </a:xfrm>
+          <a:prstGeom prst="rect">
+            <a:avLst/>
+          </a:prstGeom>
+          <a:noFill/>
+        </p:spPr>
+        <p:txBody>
+          <a:bodyPr wrap="square" rtlCol="0">
+            <a:spAutoFit/>
+          </a:bodyPr>
+          <a:lstStyle/>
+          <a:p>
+            <a:r>
+              <a:rPr lang="en-US" dirty="0"/>
+              <a:t>This is how JavaScript will read it:</a:t>
+            </a:r>
+          </a:p>
+        </p:txBody>
+      </p:sp>
+      <p:sp>
+        <p:nvSpPr>
+          <p:cNvPr id="9" name="TextBox 8">
+            <a:extLst>
+              <a:ext uri="{FF2B5EF4-FFF2-40B4-BE49-F238E27FC236}">
+                <a16:creationId xmlns:a16="http://schemas.microsoft.com/office/drawing/2014/main" id="{02FFF34D-16BD-D700-5EC6-40BE83173004}"/>
+              </a:ext>
+            </a:extLst>
+          </p:cNvPr>
+          <p:cNvSpPr txBox="1"/>
+          <p:nvPr/>
+        </p:nvSpPr>
+        <p:spPr>
+          <a:xfrm>
+            <a:off x="987779" y="4084821"/>
+            <a:ext cx="5879690" cy="383458"/>
+          </a:xfrm>
+          <a:prstGeom prst="rect">
+            <a:avLst/>
+          </a:prstGeom>
+          <a:noFill/>
+        </p:spPr>
+        <p:txBody>
+          <a:bodyPr wrap="square" rtlCol="0">
+            <a:spAutoFit/>
+          </a:bodyPr>
+          <a:lstStyle/>
+          <a:p>
+            <a:r>
+              <a:rPr lang="en-US" dirty="0"/>
+              <a:t>Output:</a:t>
+            </a:r>
+          </a:p>
+        </p:txBody>
+      </p:sp>
+      <p:pic>
+        <p:nvPicPr>
+          <p:cNvPr id="11" name="Picture 10">
+            <a:extLst>
+              <a:ext uri="{FF2B5EF4-FFF2-40B4-BE49-F238E27FC236}">
+                <a16:creationId xmlns:a16="http://schemas.microsoft.com/office/drawing/2014/main" id="{2A3A28A7-0F58-76CE-7D30-356F7DFAD1B4}"/>
+              </a:ext>
+            </a:extLst>
+          </p:cNvPr>
+          <p:cNvPicPr>
+            <a:picLocks noChangeAspect="1"/>
+          </p:cNvPicPr>
+          <p:nvPr/>
+        </p:nvPicPr>
+        <p:blipFill>
+          <a:blip r:embed="rId3"/>
+          <a:stretch>
+            <a:fillRect/>
+          </a:stretch>
+        </p:blipFill>
+        <p:spPr>
+          <a:xfrm>
+            <a:off x="1076271" y="4546935"/>
+            <a:ext cx="6590197" cy="1532199"/>
           </a:xfrm>
           <a:prstGeom prst="rect">
             <a:avLst/>
@@ -7736,7 +8121,7 @@
         <p:spPr>
           <a:xfrm>
             <a:off x="900294" y="704602"/>
-            <a:ext cx="8160152" cy="4755148"/>
+            <a:ext cx="8160152" cy="4893647"/>
           </a:xfrm>
           <a:prstGeom prst="rect">
             <a:avLst/>
@@ -7778,15 +8163,7 @@
             </a:r>
             <a:r>
               <a:rPr lang="en-US" dirty="0"/>
-              <a:t>. Similar to let, variables declared with const are hoisted but are not initialized with a value. They also remain inside the </a:t>
-            </a:r>
-            <a:r>
-              <a:rPr lang="en-US" b="1" dirty="0"/>
-              <a:t>Temporal Dead Zone (TDZ)</a:t>
-            </a:r>
-            <a:r>
-              <a:rPr lang="en-US" dirty="0"/>
-              <a:t> until the declaration is reached. Therefore, accessing a const variable before its declaration will cause an error.</a:t>
+              <a:t>. Similar to let, variables declared with const are hoisted but are not initialized with a value.</a:t>
             </a:r>
             <a:endParaRPr lang="en-US" u="sng" dirty="0">
               <a:solidFill>
@@ -7811,18 +8188,34 @@
             <a:endParaRPr lang="en-US" sz="1950" dirty="0"/>
           </a:p>
           <a:p>
-            <a:endParaRPr lang="en-US" sz="1850" dirty="0"/>
-          </a:p>
-          <a:p>
-            <a:endParaRPr lang="en-US" dirty="0"/>
+            <a:endParaRPr lang="en-US" sz="1950" dirty="0"/>
           </a:p>
           <a:p>
             <a:endParaRPr lang="en-US" sz="800" dirty="0"/>
           </a:p>
           <a:p>
+            <a:endParaRPr lang="en-US" sz="800" dirty="0"/>
+          </a:p>
+          <a:p>
             <a:r>
               <a:rPr lang="en-US" dirty="0"/>
-              <a:t>JavaScript moves the declaration of pi to the top, but the value 3.14 is not assigned immediately. Since pi is still inside the TDZ, the console.log() cannot access it and JavaScript throws a ReferenceError.</a:t>
+              <a:t>Similar to let, JavaScript moves the declaration of const pi to the top, but the value 3.14 is not assigned immediately. The variable stays in the </a:t>
+            </a:r>
+            <a:r>
+              <a:rPr lang="en-US" b="1" dirty="0"/>
+              <a:t>Temporal Dead Zone (TDZ)</a:t>
+            </a:r>
+            <a:r>
+              <a:rPr lang="en-US" dirty="0"/>
+              <a:t>. When the program runs line by line from top to bottom and it reaches console.log(pi), pi it will still be in the TDZ because its declaration has not been executed yet. As a result, JavaScript shows a </a:t>
+            </a:r>
+            <a:r>
+              <a:rPr lang="en-US" b="1" dirty="0"/>
+              <a:t>ReferenceError</a:t>
+            </a:r>
+            <a:r>
+              <a:rPr lang="en-US" dirty="0"/>
+              <a:t> and stops executing the remaining code.</a:t>
             </a:r>
           </a:p>
         </p:txBody>
@@ -7849,8 +8242,8 @@
         </p:blipFill>
         <p:spPr>
           <a:xfrm>
-            <a:off x="978930" y="2891735"/>
-            <a:ext cx="5540220" cy="1257409"/>
+            <a:off x="998614" y="2341127"/>
+            <a:ext cx="5757130" cy="1306639"/>
           </a:xfrm>
           <a:prstGeom prst="rect">
             <a:avLst/>
@@ -7907,7 +8300,7 @@
         </p:nvSpPr>
         <p:spPr>
           <a:xfrm>
-            <a:off x="1171917" y="2980442"/>
+            <a:off x="1230911" y="3508227"/>
             <a:ext cx="8160152" cy="369332"/>
           </a:xfrm>
           <a:prstGeom prst="rect">
@@ -7921,7 +8314,10 @@
           </a:bodyPr>
           <a:lstStyle/>
           <a:p>
-            <a:endParaRPr lang="en-US" dirty="0"/>
+            <a:r>
+              <a:rPr lang="en-US" dirty="0"/>
+              <a:t>Output:</a:t>
+            </a:r>
           </a:p>
         </p:txBody>
       </p:sp>
@@ -7947,7 +8343,7 @@
         </p:blipFill>
         <p:spPr>
           <a:xfrm>
-            <a:off x="1171917" y="1038241"/>
+            <a:off x="1230911" y="1441069"/>
             <a:ext cx="6759526" cy="1539373"/>
           </a:xfrm>
           <a:prstGeom prst="rect">
@@ -7957,10 +8353,10 @@
       </p:pic>
       <p:pic>
         <p:nvPicPr>
-          <p:cNvPr id="7" name="Picture 6">
+          <p:cNvPr id="5" name="Picture 4">
             <a:extLst>
               <a:ext uri="{FF2B5EF4-FFF2-40B4-BE49-F238E27FC236}">
-                <a16:creationId xmlns:a16="http://schemas.microsoft.com/office/drawing/2014/main" id="{47A6B4BA-BD6F-AA9C-05D6-323E08C36C61}"/>
+                <a16:creationId xmlns:a16="http://schemas.microsoft.com/office/drawing/2014/main" id="{B19463AC-19E3-7FE6-521C-6EDF789E963A}"/>
               </a:ext>
             </a:extLst>
           </p:cNvPr>
@@ -7977,14 +8373,49 @@
         </p:blipFill>
         <p:spPr>
           <a:xfrm>
-            <a:off x="1171917" y="3165108"/>
-            <a:ext cx="6862817" cy="1468661"/>
+            <a:off x="1171917" y="3999839"/>
+            <a:ext cx="7195634" cy="1624212"/>
           </a:xfrm>
           <a:prstGeom prst="rect">
             <a:avLst/>
           </a:prstGeom>
         </p:spPr>
       </p:pic>
+      <p:sp>
+        <p:nvSpPr>
+          <p:cNvPr id="6" name="TextBox 5">
+            <a:extLst>
+              <a:ext uri="{FF2B5EF4-FFF2-40B4-BE49-F238E27FC236}">
+                <a16:creationId xmlns:a16="http://schemas.microsoft.com/office/drawing/2014/main" id="{14EE85F5-5978-B49F-FC6A-9D9A3985E0CF}"/>
+              </a:ext>
+            </a:extLst>
+          </p:cNvPr>
+          <p:cNvSpPr txBox="1"/>
+          <p:nvPr/>
+        </p:nvSpPr>
+        <p:spPr>
+          <a:xfrm>
+            <a:off x="1171917" y="880008"/>
+            <a:ext cx="5879690" cy="383458"/>
+          </a:xfrm>
+          <a:prstGeom prst="rect">
+            <a:avLst/>
+          </a:prstGeom>
+          <a:noFill/>
+        </p:spPr>
+        <p:txBody>
+          <a:bodyPr wrap="square" rtlCol="0">
+            <a:spAutoFit/>
+          </a:bodyPr>
+          <a:lstStyle/>
+          <a:p>
+            <a:r>
+              <a:rPr lang="en-US" dirty="0"/>
+              <a:t>This is how JavaScript will read it:</a:t>
+            </a:r>
+          </a:p>
+        </p:txBody>
+      </p:sp>
     </p:spTree>
     <p:extLst>
       <p:ext uri="{BB962C8B-B14F-4D97-AF65-F5344CB8AC3E}">
@@ -8169,6 +8600,41 @@
           </a:prstGeom>
         </p:spPr>
       </p:pic>
+      <p:sp>
+        <p:nvSpPr>
+          <p:cNvPr id="3" name="TextBox 2">
+            <a:extLst>
+              <a:ext uri="{FF2B5EF4-FFF2-40B4-BE49-F238E27FC236}">
+                <a16:creationId xmlns:a16="http://schemas.microsoft.com/office/drawing/2014/main" id="{0179E826-4BE6-6148-936E-600CA2E92E31}"/>
+              </a:ext>
+            </a:extLst>
+          </p:cNvPr>
+          <p:cNvSpPr txBox="1"/>
+          <p:nvPr/>
+        </p:nvSpPr>
+        <p:spPr>
+          <a:xfrm>
+            <a:off x="7025791" y="4742225"/>
+            <a:ext cx="1469280" cy="923330"/>
+          </a:xfrm>
+          <a:prstGeom prst="rect">
+            <a:avLst/>
+          </a:prstGeom>
+          <a:noFill/>
+        </p:spPr>
+        <p:txBody>
+          <a:bodyPr wrap="square" rtlCol="0">
+            <a:spAutoFit/>
+          </a:bodyPr>
+          <a:lstStyle/>
+          <a:p>
+            <a:r>
+              <a:rPr lang="en-US" dirty="0"/>
+              <a:t>This is how JavaScript will read it:</a:t>
+            </a:r>
+          </a:p>
+        </p:txBody>
+      </p:sp>
     </p:spTree>
     <p:extLst>
       <p:ext uri="{BB962C8B-B14F-4D97-AF65-F5344CB8AC3E}">

</xml_diff>